<commit_message>
re-render w revealjs & PPTX
</commit_message>
<xml_diff>
--- a/index.pptx
+++ b/index.pptx
@@ -3372,7 +3372,9 @@
         <p:nvSpPr>
           <p:cNvPr id="1" name="TextBox 3"/>
           <p:cNvSpPr txBox="1"/>
-          <p:nvPr/>
+          <p:nvPr>
+            <p:ph idx="1"/>
+          </p:nvPr>
         </p:nvSpPr>
         <p:spPr>
           <a:xfrm>
@@ -5735,7 +5737,9 @@
         <p:nvSpPr>
           <p:cNvPr id="1" name="TextBox 3"/>
           <p:cNvSpPr txBox="1"/>
-          <p:nvPr/>
+          <p:nvPr>
+            <p:ph idx="1"/>
+          </p:nvPr>
         </p:nvSpPr>
         <p:spPr>
           <a:xfrm>
@@ -5842,7 +5846,9 @@
         <p:nvSpPr>
           <p:cNvPr id="1" name="TextBox 3"/>
           <p:cNvSpPr txBox="1"/>
-          <p:nvPr/>
+          <p:nvPr>
+            <p:ph idx="1"/>
+          </p:nvPr>
         </p:nvSpPr>
         <p:spPr>
           <a:xfrm>

</xml_diff>